<commit_message>
fix: Anthemis outreach — custom email following their pitch guidelines
- Added pitch@anthemis.com as verified contact (from anthemis.com/how-to-pitch-us)
- Upgraded Anthemis priority to 3 stars (direct pitch email = high signal)
- Updated thesis to match their current focus: fintech × AI × climate × health intersections
- Custom email follows their 5 guidelines:
  1. Short but informative (name, URL, problem, stage, location, geographies)
  2. Body-first (no reliance on attached deck)
  3. Specific Anthemis fit context (portfolio companies, intersection thesis)
  4. No tech buzzwords leading (removed Ed25519, Merkle, TPM, HSM jargon)
  5. Problem-focused framing for equal consideration
- Added customEmail override mechanism to email generator for per-investor emails
- Regenerated 484 emails, 121 HTML decks, 121 PPTX decks
</commit_message>
<xml_diff>
--- a/docs/pitch-decks/investor-100/pptx/044-anthemis.pptx
+++ b/docs/pitch-decks/investor-100/pptx/044-anthemis.pptx
@@ -2215,7 +2215,7 @@
                   <a:srgbClr val="8B8FA3"/>
                 </a:solidFill>
               </a:rPr>
-              <a:t>Personalized for Anthemis Group — European financial AI governance mandate</a:t>
+              <a:t>Personalized for Anthemis Group — AI accountability at the fintech × climate × fairness intersection</a:t>
             </a:r>
             <a:endParaRPr lang="en-US" sz="1400" dirty="0"/>
           </a:p>
@@ -2770,7 +2770,7 @@
                   <a:srgbClr val="8B8FA3"/>
                 </a:solidFill>
               </a:rPr>
-              <a:t>Financial services transformation. European-based with deep insurance and banking networks. Focus on embedded finance and regtech.</a:t>
+              <a:t>Early-stage ventures shaping the digital economy across fintech, AI, climate, health, and embedded innovation. Especially excited by founders working at the intersections of these systems. Finance as a powerful enabler.</a:t>
             </a:r>
             <a:endParaRPr lang="en-US" sz="1200" dirty="0"/>
           </a:p>
@@ -2867,7 +2867,7 @@
                   <a:srgbClr val="8B8FA3"/>
                 </a:solidFill>
               </a:rPr>
-              <a:t>Anthemis understands European financial regulation deeply. EU AI Act + DORA create immediate demand for AI governance in every European financial institution.</a:t>
+              <a:t>Anthemis invests at the intersection of fintech, AI, and climate — exactly where Datacendia sits. Every AI-driven lending decision needs fairness evidence (ECOA, CFPB). Every climate risk model needs audit trails (TCFD, TNFD). EU AI Act + DORA make this mandatory across European finance. Datacendia is the accountability layer that makes AI in financial services trustworthy and auditable.</a:t>
             </a:r>
             <a:endParaRPr lang="en-US" sz="1100" dirty="0"/>
           </a:p>
@@ -3058,7 +3058,7 @@
                   <a:srgbClr val="8B8FA3"/>
                 </a:solidFill>
               </a:rPr>
-              <a:t>Anthemis (London) specializes in financial services transformation. EU AI Act + DORA mandate AI governance across European finance. Datacendia is purpose-built for this regulatory moment.</a:t>
+              <a:t>Anthemis backs founders at the intersection of fintech × AI × climate. Datacendia is that intersection: decision evidence infrastructure proving AI lending is fair, climate risk models are governed, and every AI decision in finance has a cryptographic audit trail. EU AI Act and DORA make this mandatory.</a:t>
             </a:r>
             <a:endParaRPr lang="en-US" sz="1100" dirty="0"/>
           </a:p>
@@ -4194,7 +4194,7 @@
                   <a:srgbClr val="FFFFFF"/>
                 </a:solidFill>
               </a:rPr>
-              <a:t>European financial AI governance mandate</a:t>
+              <a:t>AI accountability at the fintech × climate × fairness intersection</a:t>
             </a:r>
             <a:endParaRPr lang="en-US" sz="1400" dirty="0"/>
           </a:p>
@@ -4252,7 +4252,7 @@
                   <a:srgbClr val="8B8FA3"/>
                 </a:solidFill>
               </a:rPr>
-              <a:t>Sector: Fintech / RegTech</a:t>
+              <a:t>Sector: Fintech / AI Governance / Climate</a:t>
             </a:r>
             <a:endParaRPr lang="en-US" sz="1200" dirty="0"/>
           </a:p>

</xml_diff>